<commit_message>
Polish Redis RAG submission wording and fallback answers
</commit_message>
<xml_diff>
--- a/slides/rag.pptx
+++ b/slides/rag.pptx
@@ -306,7 +306,7 @@
               <a:t>我</a:t>
             </a:r>
             <a:r>
-              <a:t>选的是作业二，</a:t>
+              <a:t>选择的是 Redis 垂直领域问答系统，</a:t>
             </a:r>
             <a:r>
               <a:t>这次汇报的题目是基于 RAG 的 Redis 问答系统。项目的核心目标不是简单调用大模型回答 Redis 问题，而是先把 Redis 官方文档和清洗后的技术语料构造成一个私有知识库，再通过检索增强生成的方式让答案有依据、有来源、可评估。</a:t>
@@ -383,7 +383,7 @@
               <a:t>里</a:t>
             </a:r>
             <a:r>
-              <a:t>讲生成模块。项目支持 DeepSeek，只要通过环境变量配置 DEEPSEEK_API_KEY，默认模型就是 deepseek-v4-pro。提示词里要求模型只能依据检索上下文回答，并且必须带 [1] 这样的来源引用。如果没有 API key，系统会自动使用抽取式回退，从检索片段里抽取最相关的句子组成答案。这个回退模式虽然表达没有强 LLM 那么自然，但它保证了作业在离线环境下也能完整运行，并且所有答案都来自知识库上下文。</a:t>
+              <a:t>讲生成模块。项目支持 DeepSeek，只要通过环境变量配置 DEEPSEEK_API_KEY，默认模型就是 deepseek-v4-pro。提示词里要求模型只能依据检索上下文回答，并且必须带 [1] 这样的来源引用。如果没有 API key，系统会自动使用抽取式回退，从检索片段里抽取最相关的句子组成答案。这个回退模式虽然表达没有强 LLM 那么自然，但它保证了系统在离线环境下也能完整运行，并且所有答案都来自知识库上下文。</a:t>
             </a:r>
           </a:p>
         </p:txBody>
@@ -6382,7 +6382,7 @@
                 <a:ea typeface="微软雅黑"/>
                 <a:cs typeface="微软雅黑"/>
               </a:rPr>
-              <a:t>官方文档知识库、196 个 chunk、混合检索、前端可视化展示。</a:t>
+              <a:t>官方文档知识库、166 个检索片段、混合检索、前端可视化展示。</a:t>
             </a:r>
             <a:endParaRPr sz="1220">
               <a:solidFill>
@@ -11189,7 +11189,7 @@
                 <a:ea typeface="微软雅黑"/>
                 <a:cs typeface="微软雅黑"/>
               </a:rPr>
-              <a:t>196 个检索片段</a:t>
+              <a:t>166 个检索片段</a:t>
             </a:r>
             <a:endParaRPr sz="1165" b="1">
               <a:solidFill>

</xml_diff>